<commit_message>
Despliega la mensajeria en AWS y completa la evidencia de la EP4
- Cluster de dos nodos corriendo en el EC2 con docker compose, instalado junto a Docker y
  el plugin de compose en la instancia.
- ms-notificaciones (:8084) y ms-mensajeria (:8085) como unidades systemd habilitadas,
  apuntando a los dos nodos del cluster; ms-pedidos tambien, porque ahora publica eventos.
- 17 rutas nuevas publicadas en el API Gateway (39 en total), todas con validacion JWT.
- Capturas del cluster, los exchanges, las nueve colas, la DLQ y las vistas del SPA.

La presentacion de la EP4 queda sin capturas pendientes.

Co-Authored-By: Claude Opus 5 <noreply@anthropic.com>
</commit_message>
<xml_diff>
--- a/docs/Presentacion_Pedidos360_EP4.pptx
+++ b/docs/Presentacion_Pedidos360_EP4.pptx
@@ -3530,98 +3530,87 @@
           <p:nvPr/>
         </p:nvSpPr>
         <p:spPr>
-          <a:xfrm>
+          <a:xfrm rot="72000">
+            <a:off x="8522208" y="1984248"/>
+            <a:ext cx="3072384" cy="1578478"/>
+          </a:xfrm>
+          <a:prstGeom prst="rect">
+            <a:avLst/>
+          </a:prstGeom>
+          <a:solidFill>
+            <a:srgbClr val="FFFFFF"/>
+          </a:solidFill>
+          <a:ln w="6350">
+            <a:solidFill>
+              <a:srgbClr val="D9D9D9"/>
+            </a:solidFill>
+            <a:prstDash val="solid"/>
+          </a:ln>
+          <a:effectLst>
+            <a:outerShdw sx="100000" sy="100000" kx="0" ky="0" algn="bl" rotWithShape="0" blurRad="88900" dist="38100" dir="3600000">
+              <a:srgbClr val="000000">
+                <a:alpha val="28000"/>
+              </a:srgbClr>
+            </a:outerShdw>
+          </a:effectLst>
+        </p:spPr>
+      </p:sp>
+      <p:pic>
+        <p:nvPicPr>
+          <p:cNvPr id="30" name="Image 1" descr="C:\Users\joshu\Desktop\CloudDevRamo\docs\evidencia\app-09-mensajeria.png">    </p:cNvPr>
+          <p:cNvPicPr>
+            <a:picLocks noChangeAspect="1"/>
+          </p:cNvPicPr>
+          <p:nvPr/>
+        </p:nvPicPr>
+        <p:blipFill>
+          <a:blip r:embed="rId3"/>
+          <a:stretch>
+            <a:fillRect/>
+          </a:stretch>
+        </p:blipFill>
+        <p:spPr>
+          <a:xfrm rot="72000">
             <a:off x="8595360" y="2057400"/>
-            <a:ext cx="2926080" cy="1638605"/>
-          </a:xfrm>
-          <a:prstGeom prst="roundRect">
-            <a:avLst>
-              <a:gd name="adj" fmla="val 5580"/>
-            </a:avLst>
+            <a:ext cx="2926080" cy="1432174"/>
+          </a:xfrm>
+          <a:prstGeom prst="rect">
+            <a:avLst/>
+          </a:prstGeom>
+        </p:spPr>
+      </p:pic>
+      <p:sp>
+        <p:nvSpPr>
+          <p:cNvPr id="31" name="Shape 27"/>
+          <p:cNvSpPr/>
+          <p:nvPr/>
+        </p:nvSpPr>
+        <p:spPr>
+          <a:xfrm rot="-108000">
+            <a:off x="9646920" y="1874520"/>
+            <a:ext cx="822960" cy="246888"/>
+          </a:xfrm>
+          <a:prstGeom prst="rect">
+            <a:avLst/>
           </a:prstGeom>
           <a:solidFill>
-            <a:srgbClr val="FFF6E0"/>
+            <a:srgbClr val="FFB787">
+              <a:alpha val="75000"/>
+            </a:srgbClr>
           </a:solidFill>
-          <a:ln w="25400">
+          <a:ln w="12700">
             <a:solidFill>
-              <a:srgbClr val="D9A441"/>
+              <a:srgbClr val="FFB787">
+                <a:alpha val="0"/>
+              </a:srgbClr>
             </a:solidFill>
-            <a:prstDash val="dash"/>
+            <a:prstDash val="solid"/>
           </a:ln>
         </p:spPr>
       </p:sp>
       <p:sp>
         <p:nvSpPr>
-          <p:cNvPr id="30" name="Text 27"/>
-          <p:cNvSpPr txBox="1"/>
-          <p:nvPr/>
-        </p:nvSpPr>
-        <p:spPr>
-          <a:xfrm>
-            <a:off x="8823960" y="2240280"/>
-            <a:ext cx="2468880" cy="1272845"/>
-          </a:xfrm>
-          <a:prstGeom prst="rect">
-            <a:avLst/>
-          </a:prstGeom>
-          <a:noFill/>
-          <a:ln/>
-        </p:spPr>
-        <p:txBody>
-          <a:bodyPr wrap="square" lIns="0" tIns="0" rIns="0" bIns="0" rtlCol="0" anchor="ctr"/>
-          <a:lstStyle/>
-          <a:p>
-            <a:pPr algn="ctr" indent="0" marL="0">
-              <a:buNone/>
-            </a:pPr>
-            <a:r>
-              <a:rPr lang="en-US" sz="1500" b="1" dirty="0">
-                <a:solidFill>
-                  <a:srgbClr val="8A6100"/>
-                </a:solidFill>
-                <a:latin typeface="Ink Free" pitchFamily="34" charset="0"/>
-                <a:ea typeface="Ink Free" pitchFamily="34" charset="-122"/>
-                <a:cs typeface="Ink Free" pitchFamily="34" charset="-120"/>
-              </a:rPr>
-              <a:t>CAPTURA PENDIENTE
-</a:t>
-            </a:r>
-            <a:pPr algn="ctr" indent="0" marL="0">
-              <a:buNone/>
-            </a:pPr>
-            <a:r>
-              <a:rPr lang="en-US" sz="1200" dirty="0">
-                <a:solidFill>
-                  <a:srgbClr val="8A6100"/>
-                </a:solidFill>
-                <a:latin typeface="Consolas" pitchFamily="34" charset="0"/>
-                <a:ea typeface="Consolas" pitchFamily="34" charset="-122"/>
-                <a:cs typeface="Consolas" pitchFamily="34" charset="-120"/>
-              </a:rPr>
-              <a:t>app-09-mensajeria.png
-</a:t>
-            </a:r>
-            <a:pPr algn="ctr" indent="0" marL="0">
-              <a:buNone/>
-            </a:pPr>
-            <a:r>
-              <a:rPr lang="en-US" sz="1200" dirty="0">
-                <a:solidFill>
-                  <a:srgbClr val="6B5200"/>
-                </a:solidFill>
-                <a:latin typeface="Segoe UI" pitchFamily="34" charset="0"/>
-                <a:ea typeface="Segoe UI" pitchFamily="34" charset="-122"/>
-                <a:cs typeface="Segoe UI" pitchFamily="34" charset="-120"/>
-              </a:rPr>
-              <a:t>Vista Mensajeria del SPA con la topologia y las colas</a:t>
-            </a:r>
-            <a:endParaRPr lang="en-US" sz="1500" dirty="0"/>
-          </a:p>
-        </p:txBody>
-      </p:sp>
-      <p:sp>
-        <p:nvSpPr>
-          <p:cNvPr id="31" name="Shape 28"/>
+          <p:cNvPr id="32" name="Shape 28"/>
           <p:cNvSpPr/>
           <p:nvPr/>
         </p:nvSpPr>
@@ -3653,7 +3642,7 @@
       </p:sp>
       <p:sp>
         <p:nvSpPr>
-          <p:cNvPr id="32" name="Text 29"/>
+          <p:cNvPr id="33" name="Text 29"/>
           <p:cNvSpPr txBox="1"/>
           <p:nvPr/>
         </p:nvSpPr>
@@ -4179,98 +4168,126 @@
           <p:nvPr/>
         </p:nvSpPr>
         <p:spPr>
-          <a:xfrm>
-            <a:off x="6217920" y="2057400"/>
-            <a:ext cx="5303520" cy="2969971"/>
-          </a:xfrm>
-          <a:prstGeom prst="roundRect">
-            <a:avLst>
-              <a:gd name="adj" fmla="val 3079"/>
-            </a:avLst>
+          <a:xfrm rot="60000">
+            <a:off x="6144768" y="2029968"/>
+            <a:ext cx="5449824" cy="2109024"/>
+          </a:xfrm>
+          <a:prstGeom prst="rect">
+            <a:avLst/>
           </a:prstGeom>
           <a:solidFill>
-            <a:srgbClr val="FFF6E0"/>
+            <a:srgbClr val="FFFFFF"/>
           </a:solidFill>
-          <a:ln w="25400">
+          <a:ln w="6350">
             <a:solidFill>
-              <a:srgbClr val="D9A441"/>
+              <a:srgbClr val="D9D9D9"/>
             </a:solidFill>
-            <a:prstDash val="dash"/>
+            <a:prstDash val="solid"/>
           </a:ln>
-        </p:spPr>
-      </p:sp>
-      <p:sp>
-        <p:nvSpPr>
-          <p:cNvPr id="13" name="Text 9"/>
-          <p:cNvSpPr txBox="1"/>
-          <p:nvPr/>
-        </p:nvSpPr>
-        <p:spPr>
-          <a:xfrm>
-            <a:off x="6446520" y="2240280"/>
-            <a:ext cx="4846320" cy="2604211"/>
-          </a:xfrm>
-          <a:prstGeom prst="rect">
-            <a:avLst/>
-          </a:prstGeom>
-          <a:noFill/>
-          <a:ln/>
-        </p:spPr>
-        <p:txBody>
-          <a:bodyPr wrap="square" lIns="0" tIns="0" rIns="0" bIns="0" rtlCol="0" anchor="ctr"/>
-          <a:lstStyle/>
-          <a:p>
-            <a:pPr algn="ctr" indent="0" marL="0">
-              <a:buNone/>
-            </a:pPr>
-            <a:r>
-              <a:rPr lang="en-US" sz="1500" b="1" dirty="0">
-                <a:solidFill>
-                  <a:srgbClr val="8A6100"/>
-                </a:solidFill>
-                <a:latin typeface="Ink Free" pitchFamily="34" charset="0"/>
-                <a:ea typeface="Ink Free" pitchFamily="34" charset="-122"/>
-                <a:cs typeface="Ink Free" pitchFamily="34" charset="-120"/>
-              </a:rPr>
-              <a:t>CAPTURA PENDIENTE
-</a:t>
-            </a:r>
-            <a:pPr algn="ctr" indent="0" marL="0">
-              <a:buNone/>
-            </a:pPr>
-            <a:r>
-              <a:rPr lang="en-US" sz="1200" dirty="0">
-                <a:solidFill>
-                  <a:srgbClr val="8A6100"/>
-                </a:solidFill>
-                <a:latin typeface="Consolas" pitchFamily="34" charset="0"/>
-                <a:ea typeface="Consolas" pitchFamily="34" charset="-122"/>
-                <a:cs typeface="Consolas" pitchFamily="34" charset="-120"/>
-              </a:rPr>
-              <a:t>aws-13-compose-en-ec2.png
-</a:t>
-            </a:r>
-            <a:pPr algn="ctr" indent="0" marL="0">
-              <a:buNone/>
-            </a:pPr>
-            <a:r>
-              <a:rPr lang="en-US" sz="1200" dirty="0">
-                <a:solidFill>
-                  <a:srgbClr val="6B5200"/>
-                </a:solidFill>
-                <a:latin typeface="Segoe UI" pitchFamily="34" charset="0"/>
-                <a:ea typeface="Segoe UI" pitchFamily="34" charset="-122"/>
-                <a:cs typeface="Segoe UI" pitchFamily="34" charset="-120"/>
-              </a:rPr>
-              <a:t>Terminal SSH en el EC2: docker compose up -d y cluster_status con los dos nodos</a:t>
-            </a:r>
-            <a:endParaRPr lang="en-US" sz="1500" dirty="0"/>
-          </a:p>
-        </p:txBody>
-      </p:sp>
-      <p:sp>
-        <p:nvSpPr>
-          <p:cNvPr id="14" name="Shape 10"/>
+          <a:effectLst>
+            <a:outerShdw sx="100000" sy="100000" kx="0" ky="0" algn="bl" rotWithShape="0" blurRad="88900" dist="38100" dir="3600000">
+              <a:srgbClr val="000000">
+                <a:alpha val="28000"/>
+              </a:srgbClr>
+            </a:outerShdw>
+          </a:effectLst>
+        </p:spPr>
+      </p:sp>
+      <p:pic>
+        <p:nvPicPr>
+          <p:cNvPr id="13" name="Image 2" descr="C:\Users\joshu\Desktop\CloudDevRamo\docs\evidencia\aws-13-cluster-en-ec2.png">    </p:cNvPr>
+          <p:cNvPicPr>
+            <a:picLocks noChangeAspect="1"/>
+          </p:cNvPicPr>
+          <p:nvPr/>
+        </p:nvPicPr>
+        <p:blipFill>
+          <a:blip r:embed="rId4"/>
+          <a:stretch>
+            <a:fillRect/>
+          </a:stretch>
+        </p:blipFill>
+        <p:spPr>
+          <a:xfrm rot="60000">
+            <a:off x="6217920" y="2103120"/>
+            <a:ext cx="5303520" cy="1962720"/>
+          </a:xfrm>
+          <a:prstGeom prst="rect">
+            <a:avLst/>
+          </a:prstGeom>
+        </p:spPr>
+      </p:pic>
+      <p:sp>
+        <p:nvSpPr>
+          <p:cNvPr id="14" name="Shape 9"/>
+          <p:cNvSpPr/>
+          <p:nvPr/>
+        </p:nvSpPr>
+        <p:spPr>
+          <a:xfrm rot="-120000">
+            <a:off x="8458200" y="1920240"/>
+            <a:ext cx="822960" cy="246888"/>
+          </a:xfrm>
+          <a:prstGeom prst="rect">
+            <a:avLst/>
+          </a:prstGeom>
+          <a:solidFill>
+            <a:srgbClr val="FFB787">
+              <a:alpha val="75000"/>
+            </a:srgbClr>
+          </a:solidFill>
+          <a:ln w="12700">
+            <a:solidFill>
+              <a:srgbClr val="FFB787">
+                <a:alpha val="0"/>
+              </a:srgbClr>
+            </a:solidFill>
+            <a:prstDash val="solid"/>
+          </a:ln>
+        </p:spPr>
+      </p:sp>
+      <p:sp>
+        <p:nvSpPr>
+          <p:cNvPr id="15" name="Text 10"/>
+          <p:cNvSpPr txBox="1"/>
+          <p:nvPr/>
+        </p:nvSpPr>
+        <p:spPr>
+          <a:xfrm>
+            <a:off x="6217920" y="4114800"/>
+            <a:ext cx="5303520" cy="640080"/>
+          </a:xfrm>
+          <a:prstGeom prst="rect">
+            <a:avLst/>
+          </a:prstGeom>
+          <a:noFill/>
+          <a:ln/>
+        </p:spPr>
+        <p:txBody>
+          <a:bodyPr wrap="square" lIns="0" tIns="0" rIns="0" bIns="0" rtlCol="0" anchor="t"/>
+          <a:lstStyle/>
+          <a:p>
+            <a:pPr indent="0" marL="0">
+              <a:buNone/>
+            </a:pPr>
+            <a:r>
+              <a:rPr lang="en-US" sz="1300" dirty="0">
+                <a:solidFill>
+                  <a:srgbClr val="5B6578"/>
+                </a:solidFill>
+                <a:latin typeface="Ink Free" pitchFamily="34" charset="0"/>
+                <a:ea typeface="Ink Free" pitchFamily="34" charset="-122"/>
+                <a:cs typeface="Ink Free" pitchFamily="34" charset="-120"/>
+              </a:rPr>
+              <a:t>consola del cluster DENTRO del EC2 (tunel SSH): 2 nodos, 9 colas, 10 exchanges</a:t>
+            </a:r>
+            <a:endParaRPr lang="en-US" sz="1300" dirty="0"/>
+          </a:p>
+        </p:txBody>
+      </p:sp>
+      <p:sp>
+        <p:nvSpPr>
+          <p:cNvPr id="16" name="Shape 11"/>
           <p:cNvSpPr/>
           <p:nvPr/>
         </p:nvSpPr>
@@ -4297,7 +4314,7 @@
       </p:sp>
       <p:sp>
         <p:nvSpPr>
-          <p:cNvPr id="15" name="Text 11"/>
+          <p:cNvPr id="17" name="Text 12"/>
           <p:cNvSpPr txBox="1"/>
           <p:nvPr/>
         </p:nvSpPr>
@@ -4328,7 +4345,7 @@
                 <a:ea typeface="Consolas" pitchFamily="34" charset="-122"/>
                 <a:cs typeface="Consolas" pitchFamily="34" charset="-120"/>
               </a:rPr>
-              <a:t>$ ssh -i pedidos360-lab.pem ec2-user@&lt;ip&gt;  "cd /opt/pedidos360/infra/rabbitmq &amp;&amp; docker compose up -d"</a:t>
+              <a:t>$ cd /opt/pedidos360/infra/rabbitmq &amp;&amp; sudo docker compose up -d</a:t>
             </a:r>
             <a:endParaRPr lang="en-US" sz="1150" dirty="0"/>
           </a:p>
@@ -4345,7 +4362,7 @@
                 <a:ea typeface="Consolas" pitchFamily="34" charset="-122"/>
                 <a:cs typeface="Consolas" pitchFamily="34" charset="-120"/>
               </a:rPr>
-              <a:t>$ docker exec pedidos360-rabbit1 rabbitmqctl cluster_status     →  rabbit@rabbit1, rabbit@rabbit2</a:t>
+              <a:t>   Container pedidos360-rabbit1 Started      Container pedidos360-rabbit2 Started</a:t>
             </a:r>
             <a:endParaRPr lang="en-US" sz="1150" dirty="0"/>
           </a:p>
@@ -4362,7 +4379,24 @@
                 <a:ea typeface="Consolas" pitchFamily="34" charset="-122"/>
                 <a:cs typeface="Consolas" pitchFamily="34" charset="-120"/>
               </a:rPr>
-              <a:t>$ curl https://j9w6eomnw5.execute-api.us-east-1.amazonaws.com/health   →  {"status":"UP"}</a:t>
+              <a:t>$ sudo docker exec pedidos360-rabbit1 rabbitmqctl cluster_status  →  rabbit@rabbit1  rabbit@rabbit2</a:t>
+            </a:r>
+            <a:endParaRPr lang="en-US" sz="1150" dirty="0"/>
+          </a:p>
+          <a:p>
+            <a:pPr indent="0" marL="0">
+              <a:buNone/>
+            </a:pPr>
+            <a:r>
+              <a:rPr lang="en-US" sz="1150" dirty="0">
+                <a:solidFill>
+                  <a:srgbClr val="7EE2B0"/>
+                </a:solidFill>
+                <a:latin typeface="Consolas" pitchFamily="34" charset="0"/>
+                <a:ea typeface="Consolas" pitchFamily="34" charset="-122"/>
+                <a:cs typeface="Consolas" pitchFamily="34" charset="-120"/>
+              </a:rPr>
+              <a:t>$ curl .../health → {"status":"UP"}     6 microservicios :8080-8085 respondiendo</a:t>
             </a:r>
             <a:endParaRPr lang="en-US" sz="1150" dirty="0"/>
           </a:p>

</xml_diff>